<commit_message>
TESPy Version Updates in notebooks
</commit_message>
<xml_diff>
--- a/docs/slides/03_NumericalSolving.pptx
+++ b/docs/slides/03_NumericalSolving.pptx
@@ -1227,7 +1227,7 @@
           <a:p>
             <a:fld id="{EEFC3C11-8969-431D-8429-5E6590D55DBD}" type="datetime1">
               <a:rPr lang="de-DE" smtClean="0"/>
-              <a:t>06.04.2025</a:t>
+              <a:t>20.04.2026</a:t>
             </a:fld>
             <a:endParaRPr lang="de-DE" dirty="0"/>
           </a:p>
@@ -1996,7 +1996,7 @@
           <a:p>
             <a:fld id="{5B565D63-CC46-4863-BD29-881B2F0926A6}" type="datetime1">
               <a:rPr lang="de-DE" smtClean="0"/>
-              <a:t>06.04.2025</a:t>
+              <a:t>20.04.2026</a:t>
             </a:fld>
             <a:endParaRPr lang="de-DE"/>
           </a:p>
@@ -2315,7 +2315,7 @@
           <a:p>
             <a:fld id="{5058B1EA-AD2B-454F-9B4E-9437FFBA17FD}" type="datetime1">
               <a:rPr lang="de-DE" smtClean="0"/>
-              <a:t>06.04.2025</a:t>
+              <a:t>20.04.2026</a:t>
             </a:fld>
             <a:endParaRPr lang="de-DE"/>
           </a:p>
@@ -2612,7 +2612,7 @@
           <a:p>
             <a:fld id="{E5107CED-1AA2-4CE0-AC4F-634A42864607}" type="datetime1">
               <a:rPr lang="de-DE" smtClean="0"/>
-              <a:t>06.04.2025</a:t>
+              <a:t>20.04.2026</a:t>
             </a:fld>
             <a:endParaRPr lang="de-DE"/>
           </a:p>
@@ -2905,7 +2905,7 @@
           <a:p>
             <a:fld id="{4149D238-1443-407A-A08A-E4F975BC1C20}" type="datetime1">
               <a:rPr lang="de-DE" smtClean="0"/>
-              <a:t>06.04.2025</a:t>
+              <a:t>20.04.2026</a:t>
             </a:fld>
             <a:endParaRPr lang="de-DE"/>
           </a:p>
@@ -3331,7 +3331,7 @@
           <a:p>
             <a:r>
               <a:rPr lang="de-DE" dirty="0"/>
-              <a:t>2025-04-07</a:t>
+              <a:t>2026-04-20</a:t>
             </a:r>
           </a:p>
         </p:txBody>
@@ -4565,12 +4565,6 @@
             <a:r>
               <a:rPr lang="en-US" dirty="0"/>
               <a:t>…</a:t>
-            </a:r>
-          </a:p>
-          <a:p>
-            <a:r>
-              <a:rPr lang="en-US" dirty="0"/>
-              <a:t>Have a good Easter break!</a:t>
             </a:r>
           </a:p>
         </p:txBody>

</xml_diff>